<commit_message>
docs(apresentacao): atualiza slides para refletir 6ª fonte (microdados alunos SAEB)
- Slides 3, 5, 8, 10: 5 tabelas/relatórios → 6
- Slide 5: total 34.800 → 44.800 registros (+ 10.000 microdados SAEB)
- Slide 5: menciona Base dos Dados e portal INEP como fontes
- Slide 10: bullet de relatórios inclui proficiência por município
</commit_message>
<xml_diff>
--- a/TechChallenge_Fase2/apresentacao_tech_challenge_fase2.pptx
+++ b/TechChallenge_Fase2/apresentacao_tech_challenge_fase2.pptx
@@ -3815,7 +3815,7 @@
                   <a:srgbClr val="FFFFFF"/>
                 </a:solidFill>
               </a:rPr>
-              <a:t>✔  34.800+ registros municipais integrados e validados automaticamente</a:t>
+              <a:t>✔  44.800+ registros integrados e validados (+ 10.000 microdados de alunos SAEB 2021)</a:t>
             </a:r>
           </a:p>
         </p:txBody>
@@ -3849,7 +3849,7 @@
                   <a:srgbClr val="FFFFFF"/>
                 </a:solidFill>
               </a:rPr>
-              <a:t>✔  5 relatórios prontos: ranking, risco, evolução e comparativo nacional</a:t>
+              <a:t>✔  6 relatórios prontos: ranking, risco, evolução, comparativo nacional e proficiência por município</a:t>
             </a:r>
           </a:p>
         </p:txBody>
@@ -6118,7 +6118,7 @@
                 </a:solidFill>
               </a:rPr>
               <a:t>Remove erros, duplicatas
-e une as 5 tabelas de
+e une as 6 tabelas de
 dados numa só, com
 colunas padronizadas.</a:t>
             </a:r>
@@ -6278,10 +6278,10 @@
                   <a:srgbClr val="404040"/>
                 </a:solidFill>
               </a:rPr>
-              <a:t>Gera 5 relatórios prontos
+              <a:t>Gera 6 relatórios prontos
 para uso: ranking por
 estado, municípios em
-risco, evolução anual...</a:t>
+risco, proficiência...</a:t>
             </a:r>
           </a:p>
         </p:txBody>
@@ -7555,7 +7555,7 @@
                   <a:srgbClr val="BDD7EE"/>
                 </a:solidFill>
               </a:rPr>
-              <a:t>Todos públicos e gratuitos — vêm do governo federal (INEP)</a:t>
+              <a:t>Todos públicos e gratuitos — vêm do governo federal (INEP e Base dos Dados)</a:t>
             </a:r>
           </a:p>
         </p:txBody>
@@ -7623,8 +7623,8 @@
                   <a:srgbClr val="404040"/>
                 </a:solidFill>
               </a:rPr>
-              <a:t>A pipeline integra 5 tabelas de dados do INEP (Instituto Nacional de Estudos e
-Pesquisas Educacionais), disponíveis na plataforma Base dos Dados:</a:t>
+              <a:t>A pipeline integra 6 tabelas de dados do INEP (Instituto Nacional de Estudos e
+Pesquisas Educacionais), disponíveis na plataforma Base dos Dados e no portal do INEP:</a:t>
             </a:r>
           </a:p>
         </p:txBody>
@@ -9092,7 +9092,7 @@
                   <a:srgbClr val="1F4E79"/>
                 </a:solidFill>
               </a:rPr>
-              <a:t>Total: mais de 34.800 registros municipais integrados e validados automaticamente.</a:t>
+              <a:t>Total: mais de 44.800 registros integrados e validados automaticamente (+ 10.000 microdados de alunos SAEB).</a:t>
             </a:r>
           </a:p>
         </p:txBody>
@@ -11385,7 +11385,7 @@
                   <a:srgbClr val="FFFFFF"/>
                 </a:solidFill>
               </a:rPr>
-              <a:t>~ $2,91 / </a:t>
+              <a:t xml:space="preserve">~ $2,91 / </a:t>
             </a:r>
             <a:r>
               <a:rPr sz="1200" b="1" i="0" dirty="0" err="1">
@@ -11694,7 +11694,7 @@
                   <a:srgbClr val="BDD7EE"/>
                 </a:solidFill>
               </a:rPr>
-              <a:t>5 relatórios prontos para uso — a camada Gold</a:t>
+              <a:t>6 relatórios prontos para uso — a camada Gold</a:t>
             </a:r>
           </a:p>
         </p:txBody>
@@ -11762,7 +11762,7 @@
                   <a:srgbClr val="404040"/>
                 </a:solidFill>
               </a:rPr>
-              <a:t>A camada final (Gold) produz 5 conjuntos de dados prontos para serem usados
+              <a:t>A camada final (Gold) produz 6 conjuntos de dados prontos para serem usados
 em dashboards, Excel, Power BI ou para alimentar modelos de Inteligência Artificial.</a:t>
             </a:r>
           </a:p>

</xml_diff>